<commit_message>
Ship the chapter break on the pale ground
The pale version is the one going into the deck, so it is what the script builds by
default; --dark still produces the graphite variant.
</commit_message>
<xml_diff>
--- a/slides/section_adaptation_cost.pptx
+++ b/slides/section_adaptation_cost.pptx
@@ -3553,7 +3553,7 @@
     <p:bg>
       <p:bgPr>
         <a:solidFill>
-          <a:srgbClr val="16202A"/>
+          <a:srgbClr val="F6F7F9"/>
         </a:solidFill>
         <a:effectLst/>
       </p:bgPr>
@@ -3585,7 +3585,7 @@
           <a:noFill/>
           <a:ln w="38100">
             <a:solidFill>
-              <a:srgbClr val="263340"/>
+              <a:srgbClr val="E6EAEE"/>
             </a:solidFill>
             <a:tailEnd type="triangle" w="med" len="med"/>
           </a:ln>
@@ -3634,7 +3634,7 @@
             <a:r>
               <a:rPr sz="1200" b="1">
                 <a:solidFill>
-                  <a:srgbClr val="F2B233"/>
+                  <a:srgbClr val="C0612C"/>
                 </a:solidFill>
                 <a:latin typeface="Consolas"/>
                 <a:ea typeface="Microsoft YaHei"/>
@@ -3681,7 +3681,7 @@
             <a:r>
               <a:rPr sz="4200" b="1">
                 <a:solidFill>
-                  <a:srgbClr val="FFFFFF"/>
+                  <a:srgbClr val="16202A"/>
                 </a:solidFill>
                 <a:latin typeface="Microsoft YaHei"/>
                 <a:ea typeface="Microsoft YaHei"/>
@@ -3708,7 +3708,7 @@
           </a:prstGeom>
           <a:ln w="31750">
             <a:solidFill>
-              <a:srgbClr val="E99A66"/>
+              <a:srgbClr val="C0612C"/>
             </a:solidFill>
           </a:ln>
         </p:spPr>
@@ -3749,7 +3749,7 @@
             <a:r>
               <a:rPr sz="1500" b="0">
                 <a:solidFill>
-                  <a:srgbClr val="8C96A1"/>
+                  <a:srgbClr val="66727F"/>
                 </a:solidFill>
                 <a:latin typeface="Microsoft YaHei"/>
                 <a:ea typeface="Microsoft YaHei"/>
@@ -3796,7 +3796,7 @@
             <a:r>
               <a:rPr sz="1000" b="0">
                 <a:solidFill>
-                  <a:srgbClr val="66727F"/>
+                  <a:srgbClr val="8C96A1"/>
                 </a:solidFill>
                 <a:latin typeface="Consolas"/>
                 <a:ea typeface="Microsoft YaHei"/>

</xml_diff>